<commit_message>
Update the stat orientation to 2025
</commit_message>
<xml_diff>
--- a/Stat Orientation Lab.pptx
+++ b/Stat Orientation Lab.pptx
@@ -265,6 +265,35 @@
     </p:ext>
   </p:extLst>
 </p:presentation>
+</file>
+
+<file path=ppt/changesInfos/changesInfo1.xml><?xml version="1.0" encoding="utf-8"?>
+<pc:chgInfo xmlns:a="http://schemas.openxmlformats.org/drawingml/2006/main" xmlns:r="http://schemas.openxmlformats.org/officeDocument/2006/relationships" xmlns:ac="http://schemas.microsoft.com/office/drawing/2013/main/command" xmlns:pc="http://schemas.microsoft.com/office/powerpoint/2013/main/command">
+  <pc:docChgLst>
+    <pc:chgData name="Yang,Peng" userId="42d342d1-35a9-4cd4-8796-d8cf994d69af" providerId="ADAL" clId="{F40F5D20-6146-D54C-BBAB-80A4DE0918FB}"/>
+    <pc:docChg chg="modSld">
+      <pc:chgData name="Yang,Peng" userId="42d342d1-35a9-4cd4-8796-d8cf994d69af" providerId="ADAL" clId="{F40F5D20-6146-D54C-BBAB-80A4DE0918FB}" dt="2025-08-20T14:49:51.233" v="1" actId="20577"/>
+      <pc:docMkLst>
+        <pc:docMk/>
+      </pc:docMkLst>
+      <pc:sldChg chg="modSp mod">
+        <pc:chgData name="Yang,Peng" userId="42d342d1-35a9-4cd4-8796-d8cf994d69af" providerId="ADAL" clId="{F40F5D20-6146-D54C-BBAB-80A4DE0918FB}" dt="2025-08-20T14:49:51.233" v="1" actId="20577"/>
+        <pc:sldMkLst>
+          <pc:docMk/>
+          <pc:sldMk cId="0" sldId="256"/>
+        </pc:sldMkLst>
+        <pc:spChg chg="mod">
+          <ac:chgData name="Yang,Peng" userId="42d342d1-35a9-4cd4-8796-d8cf994d69af" providerId="ADAL" clId="{F40F5D20-6146-D54C-BBAB-80A4DE0918FB}" dt="2025-08-20T14:49:51.233" v="1" actId="20577"/>
+          <ac:spMkLst>
+            <pc:docMk/>
+            <pc:sldMk cId="0" sldId="256"/>
+            <ac:spMk id="55" creationId="{00000000-0000-0000-0000-000000000000}"/>
+          </ac:spMkLst>
+        </pc:spChg>
+      </pc:sldChg>
+    </pc:docChg>
+  </pc:docChgLst>
+</pc:chgInfo>
 </file>
 
 <file path=ppt/notesMasters/notesMaster1.xml><?xml version="1.0" encoding="utf-8"?>
@@ -6399,8 +6428,8 @@
               <a:buNone/>
             </a:pPr>
             <a:r>
-              <a:rPr lang="en" dirty="0"/>
-              <a:t>8/21/2024</a:t>
+              <a:rPr lang="en"/>
+              <a:t>8/20/2025</a:t>
             </a:r>
             <a:endParaRPr dirty="0"/>
           </a:p>

</xml_diff>

<commit_message>
Update the ppt back to 2024
</commit_message>
<xml_diff>
--- a/Stat Orientation Lab.pptx
+++ b/Stat Orientation Lab.pptx
@@ -272,18 +272,18 @@
   <pc:docChgLst>
     <pc:chgData name="Yang,Peng" userId="42d342d1-35a9-4cd4-8796-d8cf994d69af" providerId="ADAL" clId="{F40F5D20-6146-D54C-BBAB-80A4DE0918FB}"/>
     <pc:docChg chg="modSld">
-      <pc:chgData name="Yang,Peng" userId="42d342d1-35a9-4cd4-8796-d8cf994d69af" providerId="ADAL" clId="{F40F5D20-6146-D54C-BBAB-80A4DE0918FB}" dt="2025-08-20T14:49:51.233" v="1" actId="20577"/>
+      <pc:chgData name="Yang,Peng" userId="42d342d1-35a9-4cd4-8796-d8cf994d69af" providerId="ADAL" clId="{F40F5D20-6146-D54C-BBAB-80A4DE0918FB}" dt="2025-08-20T14:50:48.580" v="3" actId="20577"/>
       <pc:docMkLst>
         <pc:docMk/>
       </pc:docMkLst>
       <pc:sldChg chg="modSp mod">
-        <pc:chgData name="Yang,Peng" userId="42d342d1-35a9-4cd4-8796-d8cf994d69af" providerId="ADAL" clId="{F40F5D20-6146-D54C-BBAB-80A4DE0918FB}" dt="2025-08-20T14:49:51.233" v="1" actId="20577"/>
+        <pc:chgData name="Yang,Peng" userId="42d342d1-35a9-4cd4-8796-d8cf994d69af" providerId="ADAL" clId="{F40F5D20-6146-D54C-BBAB-80A4DE0918FB}" dt="2025-08-20T14:50:48.580" v="3" actId="20577"/>
         <pc:sldMkLst>
           <pc:docMk/>
           <pc:sldMk cId="0" sldId="256"/>
         </pc:sldMkLst>
         <pc:spChg chg="mod">
-          <ac:chgData name="Yang,Peng" userId="42d342d1-35a9-4cd4-8796-d8cf994d69af" providerId="ADAL" clId="{F40F5D20-6146-D54C-BBAB-80A4DE0918FB}" dt="2025-08-20T14:49:51.233" v="1" actId="20577"/>
+          <ac:chgData name="Yang,Peng" userId="42d342d1-35a9-4cd4-8796-d8cf994d69af" providerId="ADAL" clId="{F40F5D20-6146-D54C-BBAB-80A4DE0918FB}" dt="2025-08-20T14:50:48.580" v="3" actId="20577"/>
           <ac:spMkLst>
             <pc:docMk/>
             <pc:sldMk cId="0" sldId="256"/>
@@ -6429,7 +6429,7 @@
             </a:pPr>
             <a:r>
               <a:rPr lang="en"/>
-              <a:t>8/20/2025</a:t>
+              <a:t>8/21/2024</a:t>
             </a:r>
             <a:endParaRPr dirty="0"/>
           </a:p>

</xml_diff>